<commit_message>
Fix optical alignment and audit Dayova template layouts
</commit_message>
<xml_diff>
--- a/brand/templates/dist/Dayova-Presentation.pptx
+++ b/brand/templates/dist/Dayova-Presentation.pptx
@@ -5936,23 +5936,23 @@
         </p:nvSpPr>
         <p:spPr>
           <a:xfrm>
-            <a:off x="8467725" y="4695825"/>
-            <a:ext cx="666750" cy="381000"/>
-          </a:xfrm>
-          <a:prstGeom prst="rect">
-            <a:avLst/>
-          </a:prstGeom>
-          <a:noFill/>
-        </p:spPr>
-        <p:txBody>
-          <a:bodyPr wrap="square" lIns="0" rIns="0" tIns="0" bIns="0">
+            <a:off x="8467725" y="4543425"/>
+            <a:ext cx="666750" cy="666750"/>
+          </a:xfrm>
+          <a:prstGeom prst="rect">
+            <a:avLst/>
+          </a:prstGeom>
+          <a:noFill/>
+        </p:spPr>
+        <p:txBody>
+          <a:bodyPr wrap="square" lIns="0" rIns="0" tIns="10239" bIns="0" anchor="ctr">
             <a:spAutoFit/>
           </a:bodyPr>
           <a:lstStyle/>
           <a:p>
             <a:pPr algn="ctr">
               <a:lnSpc>
-                <a:spcPct val="125000"/>
+                <a:spcPct val="100000"/>
               </a:lnSpc>
               <a:spcBef>
                 <a:spcPts val="0"/>
@@ -6024,23 +6024,23 @@
         </p:nvSpPr>
         <p:spPr>
           <a:xfrm>
-            <a:off x="10191750" y="3781425"/>
-            <a:ext cx="666750" cy="381000"/>
-          </a:xfrm>
-          <a:prstGeom prst="rect">
-            <a:avLst/>
-          </a:prstGeom>
-          <a:noFill/>
-        </p:spPr>
-        <p:txBody>
-          <a:bodyPr wrap="square" lIns="0" rIns="0" tIns="0" bIns="0">
+            <a:off x="10191750" y="3629025"/>
+            <a:ext cx="666750" cy="666750"/>
+          </a:xfrm>
+          <a:prstGeom prst="rect">
+            <a:avLst/>
+          </a:prstGeom>
+          <a:noFill/>
+        </p:spPr>
+        <p:txBody>
+          <a:bodyPr wrap="square" lIns="0" rIns="0" tIns="10715" bIns="0" anchor="ctr">
             <a:spAutoFit/>
           </a:bodyPr>
           <a:lstStyle/>
           <a:p>
             <a:pPr algn="ctr">
               <a:lnSpc>
-                <a:spcPct val="125000"/>
+                <a:spcPct val="100000"/>
               </a:lnSpc>
               <a:spcBef>
                 <a:spcPts val="0"/>
@@ -6112,23 +6112,23 @@
         </p:nvSpPr>
         <p:spPr>
           <a:xfrm>
-            <a:off x="8629650" y="2705100"/>
-            <a:ext cx="666750" cy="381000"/>
-          </a:xfrm>
-          <a:prstGeom prst="rect">
-            <a:avLst/>
-          </a:prstGeom>
-          <a:noFill/>
-        </p:spPr>
-        <p:txBody>
-          <a:bodyPr wrap="square" lIns="0" rIns="0" tIns="0" bIns="0">
+            <a:off x="8629650" y="2552700"/>
+            <a:ext cx="666750" cy="666750"/>
+          </a:xfrm>
+          <a:prstGeom prst="rect">
+            <a:avLst/>
+          </a:prstGeom>
+          <a:noFill/>
+        </p:spPr>
+        <p:txBody>
+          <a:bodyPr wrap="square" lIns="0" rIns="0" tIns="9763" bIns="0" anchor="ctr">
             <a:spAutoFit/>
           </a:bodyPr>
           <a:lstStyle/>
           <a:p>
             <a:pPr algn="ctr">
               <a:lnSpc>
-                <a:spcPct val="125000"/>
+                <a:spcPct val="100000"/>
               </a:lnSpc>
               <a:spcBef>
                 <a:spcPts val="0"/>
@@ -6200,23 +6200,23 @@
         </p:nvSpPr>
         <p:spPr>
           <a:xfrm>
-            <a:off x="10191750" y="1876425"/>
-            <a:ext cx="666750" cy="381000"/>
-          </a:xfrm>
-          <a:prstGeom prst="rect">
-            <a:avLst/>
-          </a:prstGeom>
-          <a:noFill/>
-        </p:spPr>
-        <p:txBody>
-          <a:bodyPr wrap="square" lIns="0" rIns="0" tIns="0" bIns="0">
+            <a:off x="10191750" y="1724025"/>
+            <a:ext cx="666750" cy="666750"/>
+          </a:xfrm>
+          <a:prstGeom prst="rect">
+            <a:avLst/>
+          </a:prstGeom>
+          <a:noFill/>
+        </p:spPr>
+        <p:txBody>
+          <a:bodyPr wrap="square" lIns="0" rIns="0" tIns="10239" bIns="0" anchor="ctr">
             <a:spAutoFit/>
           </a:bodyPr>
           <a:lstStyle/>
           <a:p>
             <a:pPr algn="ctr">
               <a:lnSpc>
-                <a:spcPct val="125000"/>
+                <a:spcPct val="100000"/>
               </a:lnSpc>
               <a:spcBef>
                 <a:spcPts val="0"/>
@@ -8763,7 +8763,7 @@
                       </a:r>
                     </a:p>
                   </a:txBody>
-                  <a:tcPr marL="164592" marT="173736">
+                  <a:tcPr marL="164592" marT="0" marB="0" anchor="ctr">
                     <a:solidFill>
                       <a:srgbClr val="1A1A1A"/>
                     </a:solidFill>
@@ -8787,7 +8787,7 @@
                       </a:r>
                     </a:p>
                   </a:txBody>
-                  <a:tcPr marL="164592" marT="173736">
+                  <a:tcPr marL="164592" marT="0" marB="0" anchor="ctr">
                     <a:solidFill>
                       <a:srgbClr val="1A1A1A"/>
                     </a:solidFill>
@@ -8811,7 +8811,7 @@
                       </a:r>
                     </a:p>
                   </a:txBody>
-                  <a:tcPr marL="164592" marT="173736">
+                  <a:tcPr marL="164592" marT="0" marB="0" anchor="ctr">
                     <a:solidFill>
                       <a:srgbClr val="1A1A1A"/>
                     </a:solidFill>
@@ -8835,7 +8835,7 @@
                       </a:r>
                     </a:p>
                   </a:txBody>
-                  <a:tcPr marL="164592" marT="173736">
+                  <a:tcPr marL="164592" marT="0" marB="0" anchor="ctr">
                     <a:solidFill>
                       <a:srgbClr val="1A1A1A"/>
                     </a:solidFill>
@@ -8861,7 +8861,7 @@
                       </a:r>
                     </a:p>
                   </a:txBody>
-                  <a:tcPr marL="164592" marT="173736">
+                  <a:tcPr marL="164592" marT="0" marB="0" anchor="ctr">
                     <a:solidFill>
                       <a:srgbClr val="FFFFFF"/>
                     </a:solidFill>
@@ -8885,7 +8885,7 @@
                       </a:r>
                     </a:p>
                   </a:txBody>
-                  <a:tcPr marL="164592" marT="173736">
+                  <a:tcPr marL="164592" marT="0" marB="0" anchor="ctr">
                     <a:solidFill>
                       <a:srgbClr val="FFFFFF"/>
                     </a:solidFill>
@@ -8909,7 +8909,7 @@
                       </a:r>
                     </a:p>
                   </a:txBody>
-                  <a:tcPr marL="164592" marT="173736">
+                  <a:tcPr marL="164592" marT="0" marB="0" anchor="ctr">
                     <a:solidFill>
                       <a:srgbClr val="FFFFFF"/>
                     </a:solidFill>
@@ -8933,7 +8933,7 @@
                       </a:r>
                     </a:p>
                   </a:txBody>
-                  <a:tcPr marL="164592" marT="173736">
+                  <a:tcPr marL="164592" marT="0" marB="0" anchor="ctr">
                     <a:solidFill>
                       <a:srgbClr val="FFFFFF"/>
                     </a:solidFill>
@@ -8959,7 +8959,7 @@
                       </a:r>
                     </a:p>
                   </a:txBody>
-                  <a:tcPr marL="164592" marT="173736">
+                  <a:tcPr marL="164592" marT="0" marB="0" anchor="ctr">
                     <a:solidFill>
                       <a:srgbClr val="F1F7FB"/>
                     </a:solidFill>
@@ -8983,7 +8983,7 @@
                       </a:r>
                     </a:p>
                   </a:txBody>
-                  <a:tcPr marL="164592" marT="173736">
+                  <a:tcPr marL="164592" marT="0" marB="0" anchor="ctr">
                     <a:solidFill>
                       <a:srgbClr val="F1F7FB"/>
                     </a:solidFill>
@@ -9007,7 +9007,7 @@
                       </a:r>
                     </a:p>
                   </a:txBody>
-                  <a:tcPr marL="164592" marT="173736">
+                  <a:tcPr marL="164592" marT="0" marB="0" anchor="ctr">
                     <a:solidFill>
                       <a:srgbClr val="F1F7FB"/>
                     </a:solidFill>
@@ -9031,7 +9031,7 @@
                       </a:r>
                     </a:p>
                   </a:txBody>
-                  <a:tcPr marL="164592" marT="173736">
+                  <a:tcPr marL="164592" marT="0" marB="0" anchor="ctr">
                     <a:solidFill>
                       <a:srgbClr val="F1F7FB"/>
                     </a:solidFill>
@@ -9057,7 +9057,7 @@
                       </a:r>
                     </a:p>
                   </a:txBody>
-                  <a:tcPr marL="164592" marT="173736">
+                  <a:tcPr marL="164592" marT="0" marB="0" anchor="ctr">
                     <a:solidFill>
                       <a:srgbClr val="FFFFFF"/>
                     </a:solidFill>
@@ -9081,7 +9081,7 @@
                       </a:r>
                     </a:p>
                   </a:txBody>
-                  <a:tcPr marL="164592" marT="173736">
+                  <a:tcPr marL="164592" marT="0" marB="0" anchor="ctr">
                     <a:solidFill>
                       <a:srgbClr val="FFFFFF"/>
                     </a:solidFill>
@@ -9105,7 +9105,7 @@
                       </a:r>
                     </a:p>
                   </a:txBody>
-                  <a:tcPr marL="164592" marT="173736">
+                  <a:tcPr marL="164592" marT="0" marB="0" anchor="ctr">
                     <a:solidFill>
                       <a:srgbClr val="FFFFFF"/>
                     </a:solidFill>
@@ -9129,7 +9129,7 @@
                       </a:r>
                     </a:p>
                   </a:txBody>
-                  <a:tcPr marL="164592" marT="173736">
+                  <a:tcPr marL="164592" marT="0" marB="0" anchor="ctr">
                     <a:solidFill>
                       <a:srgbClr val="FFFFFF"/>
                     </a:solidFill>
@@ -11084,7 +11084,7 @@
         </p:nvSpPr>
         <p:spPr>
           <a:xfrm>
-            <a:off x="1438275" y="2990850"/>
+            <a:off x="1447800" y="2990850"/>
             <a:ext cx="1676400" cy="1676400"/>
           </a:xfrm>
           <a:prstGeom prst="ellipse">
@@ -11127,23 +11127,23 @@
         </p:nvSpPr>
         <p:spPr>
           <a:xfrm>
-            <a:off x="1438275" y="3505200"/>
-            <a:ext cx="1676400" cy="666750"/>
-          </a:xfrm>
-          <a:prstGeom prst="rect">
-            <a:avLst/>
-          </a:prstGeom>
-          <a:noFill/>
-        </p:spPr>
-        <p:txBody>
-          <a:bodyPr wrap="square" lIns="0" rIns="0" tIns="0" bIns="0">
+            <a:off x="1447800" y="2990850"/>
+            <a:ext cx="1676400" cy="1676400"/>
+          </a:xfrm>
+          <a:prstGeom prst="rect">
+            <a:avLst/>
+          </a:prstGeom>
+          <a:noFill/>
+        </p:spPr>
+        <p:txBody>
+          <a:bodyPr wrap="square" lIns="0" rIns="0" tIns="10287" bIns="0" anchor="ctr">
             <a:spAutoFit/>
           </a:bodyPr>
           <a:lstStyle/>
           <a:p>
             <a:pPr algn="ctr">
               <a:lnSpc>
-                <a:spcPct val="125000"/>
+                <a:spcPct val="100000"/>
               </a:lnSpc>
               <a:spcBef>
                 <a:spcPts val="0"/>
@@ -11262,7 +11262,7 @@
         </p:nvSpPr>
         <p:spPr>
           <a:xfrm>
-            <a:off x="5248275" y="2990850"/>
+            <a:off x="5257800" y="2990850"/>
             <a:ext cx="1676400" cy="1676400"/>
           </a:xfrm>
           <a:prstGeom prst="ellipse">
@@ -11305,23 +11305,23 @@
         </p:nvSpPr>
         <p:spPr>
           <a:xfrm>
-            <a:off x="5248275" y="3505200"/>
-            <a:ext cx="1676400" cy="666750"/>
-          </a:xfrm>
-          <a:prstGeom prst="rect">
-            <a:avLst/>
-          </a:prstGeom>
-          <a:noFill/>
-        </p:spPr>
-        <p:txBody>
-          <a:bodyPr wrap="square" lIns="0" rIns="0" tIns="0" bIns="0">
+            <a:off x="5257800" y="2990850"/>
+            <a:ext cx="1676400" cy="1676400"/>
+          </a:xfrm>
+          <a:prstGeom prst="rect">
+            <a:avLst/>
+          </a:prstGeom>
+          <a:noFill/>
+        </p:spPr>
+        <p:txBody>
+          <a:bodyPr wrap="square" lIns="0" rIns="0" tIns="10287" bIns="0" anchor="ctr">
             <a:spAutoFit/>
           </a:bodyPr>
           <a:lstStyle/>
           <a:p>
             <a:pPr algn="ctr">
               <a:lnSpc>
-                <a:spcPct val="125000"/>
+                <a:spcPct val="100000"/>
               </a:lnSpc>
               <a:spcBef>
                 <a:spcPts val="0"/>
@@ -11440,7 +11440,7 @@
         </p:nvSpPr>
         <p:spPr>
           <a:xfrm>
-            <a:off x="9058275" y="2990850"/>
+            <a:off x="9067800" y="2990850"/>
             <a:ext cx="1676400" cy="1676400"/>
           </a:xfrm>
           <a:prstGeom prst="ellipse">
@@ -11483,23 +11483,23 @@
         </p:nvSpPr>
         <p:spPr>
           <a:xfrm>
-            <a:off x="9058275" y="3505200"/>
-            <a:ext cx="1676400" cy="666750"/>
-          </a:xfrm>
-          <a:prstGeom prst="rect">
-            <a:avLst/>
-          </a:prstGeom>
-          <a:noFill/>
-        </p:spPr>
-        <p:txBody>
-          <a:bodyPr wrap="square" lIns="0" rIns="0" tIns="0" bIns="0">
+            <a:off x="9067800" y="2990850"/>
+            <a:ext cx="1676400" cy="1676400"/>
+          </a:xfrm>
+          <a:prstGeom prst="rect">
+            <a:avLst/>
+          </a:prstGeom>
+          <a:noFill/>
+        </p:spPr>
+        <p:txBody>
+          <a:bodyPr wrap="square" lIns="0" rIns="0" tIns="10287" bIns="0" anchor="ctr">
             <a:spAutoFit/>
           </a:bodyPr>
           <a:lstStyle/>
           <a:p>
             <a:pPr algn="ctr">
               <a:lnSpc>
-                <a:spcPct val="125000"/>
+                <a:spcPct val="100000"/>
               </a:lnSpc>
               <a:spcBef>
                 <a:spcPts val="0"/>
@@ -12842,23 +12842,23 @@
         </p:nvSpPr>
         <p:spPr>
           <a:xfrm>
-            <a:off x="1085850" y="5038725"/>
-            <a:ext cx="2990850" cy="428625"/>
-          </a:xfrm>
-          <a:prstGeom prst="rect">
-            <a:avLst/>
-          </a:prstGeom>
-          <a:noFill/>
-        </p:spPr>
-        <p:txBody>
-          <a:bodyPr wrap="square" lIns="0" rIns="0" tIns="0" bIns="0">
+            <a:off x="1085850" y="4876800"/>
+            <a:ext cx="2990850" cy="609600"/>
+          </a:xfrm>
+          <a:prstGeom prst="rect">
+            <a:avLst/>
+          </a:prstGeom>
+          <a:noFill/>
+        </p:spPr>
+        <p:txBody>
+          <a:bodyPr wrap="square" lIns="0" rIns="0" tIns="5657" bIns="0" anchor="ctr">
             <a:spAutoFit/>
           </a:bodyPr>
           <a:lstStyle/>
           <a:p>
             <a:pPr algn="ctr">
               <a:lnSpc>
-                <a:spcPct val="125000"/>
+                <a:spcPct val="100000"/>
               </a:lnSpc>
               <a:spcBef>
                 <a:spcPts val="0"/>
@@ -13985,7 +13985,7 @@
       </p:sp>
       <p:sp>
         <p:nvSpPr>
-          <p:cNvPr id="25" name="Titel → Aussage → Abschnitt → Text"/>
+          <p:cNvPr id="25" name="Titel / Aussage / Abschnitt / Text"/>
           <p:cNvSpPr txBox="1"/>
           <p:nvPr/>
         </p:nvSpPr>
@@ -14023,7 +14023,7 @@
               </a:defRPr>
             </a:pPr>
             <a:r>
-              <a:t>Titel → Aussage → Abschnitt → Text</a:t>
+              <a:t>Titel / Aussage / Abschnitt / Text</a:t>
             </a:r>
           </a:p>
         </p:txBody>
@@ -19738,23 +19738,23 @@
         </p:nvSpPr>
         <p:spPr>
           <a:xfrm>
-            <a:off x="533400" y="3314700"/>
-            <a:ext cx="609600" cy="419100"/>
-          </a:xfrm>
-          <a:prstGeom prst="rect">
-            <a:avLst/>
-          </a:prstGeom>
-          <a:noFill/>
-        </p:spPr>
-        <p:txBody>
-          <a:bodyPr wrap="square" lIns="0" rIns="0" tIns="0" bIns="0">
+            <a:off x="533400" y="3209925"/>
+            <a:ext cx="609600" cy="609600"/>
+          </a:xfrm>
+          <a:prstGeom prst="rect">
+            <a:avLst/>
+          </a:prstGeom>
+          <a:noFill/>
+        </p:spPr>
+        <p:txBody>
+          <a:bodyPr wrap="square" lIns="0" rIns="0" tIns="7734" bIns="0" anchor="ctr">
             <a:spAutoFit/>
           </a:bodyPr>
           <a:lstStyle/>
           <a:p>
             <a:pPr algn="ctr">
               <a:lnSpc>
-                <a:spcPct val="125000"/>
+                <a:spcPct val="100000"/>
               </a:lnSpc>
               <a:spcBef>
                 <a:spcPts val="0"/>
@@ -19783,8 +19783,8 @@
         </p:nvSpPr>
         <p:spPr>
           <a:xfrm>
-            <a:off x="1343025" y="3486150"/>
-            <a:ext cx="1876425" cy="28575"/>
+            <a:off x="1333500" y="3500437"/>
+            <a:ext cx="1866899" cy="28575"/>
           </a:xfrm>
           <a:prstGeom prst="rect">
             <a:avLst/>
@@ -19981,23 +19981,23 @@
         </p:nvSpPr>
         <p:spPr>
           <a:xfrm>
-            <a:off x="3390900" y="3314700"/>
-            <a:ext cx="609600" cy="419100"/>
-          </a:xfrm>
-          <a:prstGeom prst="rect">
-            <a:avLst/>
-          </a:prstGeom>
-          <a:noFill/>
-        </p:spPr>
-        <p:txBody>
-          <a:bodyPr wrap="square" lIns="0" rIns="0" tIns="0" bIns="0">
+            <a:off x="3390900" y="3209925"/>
+            <a:ext cx="609600" cy="609600"/>
+          </a:xfrm>
+          <a:prstGeom prst="rect">
+            <a:avLst/>
+          </a:prstGeom>
+          <a:noFill/>
+        </p:spPr>
+        <p:txBody>
+          <a:bodyPr wrap="square" lIns="0" rIns="0" tIns="12001" bIns="0" anchor="ctr">
             <a:spAutoFit/>
           </a:bodyPr>
           <a:lstStyle/>
           <a:p>
             <a:pPr algn="ctr">
               <a:lnSpc>
-                <a:spcPct val="125000"/>
+                <a:spcPct val="100000"/>
               </a:lnSpc>
               <a:spcBef>
                 <a:spcPts val="0"/>
@@ -20026,8 +20026,8 @@
         </p:nvSpPr>
         <p:spPr>
           <a:xfrm>
-            <a:off x="4200525" y="3486150"/>
-            <a:ext cx="1876425" cy="28575"/>
+            <a:off x="4190999" y="3500437"/>
+            <a:ext cx="1866899" cy="28575"/>
           </a:xfrm>
           <a:prstGeom prst="rect">
             <a:avLst/>
@@ -20224,23 +20224,23 @@
         </p:nvSpPr>
         <p:spPr>
           <a:xfrm>
-            <a:off x="6248400" y="3314700"/>
-            <a:ext cx="609600" cy="419100"/>
-          </a:xfrm>
-          <a:prstGeom prst="rect">
-            <a:avLst/>
-          </a:prstGeom>
-          <a:noFill/>
-        </p:spPr>
-        <p:txBody>
-          <a:bodyPr wrap="square" lIns="0" rIns="0" tIns="0" bIns="0">
+            <a:off x="6248400" y="3209925"/>
+            <a:ext cx="609600" cy="609600"/>
+          </a:xfrm>
+          <a:prstGeom prst="rect">
+            <a:avLst/>
+          </a:prstGeom>
+          <a:noFill/>
+        </p:spPr>
+        <p:txBody>
+          <a:bodyPr wrap="square" lIns="0" rIns="0" tIns="10934" bIns="0" anchor="ctr">
             <a:spAutoFit/>
           </a:bodyPr>
           <a:lstStyle/>
           <a:p>
             <a:pPr algn="ctr">
               <a:lnSpc>
-                <a:spcPct val="125000"/>
+                <a:spcPct val="100000"/>
               </a:lnSpc>
               <a:spcBef>
                 <a:spcPts val="0"/>
@@ -20269,8 +20269,8 @@
         </p:nvSpPr>
         <p:spPr>
           <a:xfrm>
-            <a:off x="7058025" y="3486150"/>
-            <a:ext cx="1876425" cy="28575"/>
+            <a:off x="7048500" y="3500437"/>
+            <a:ext cx="1866899" cy="28575"/>
           </a:xfrm>
           <a:prstGeom prst="rect">
             <a:avLst/>
@@ -20467,23 +20467,23 @@
         </p:nvSpPr>
         <p:spPr>
           <a:xfrm>
-            <a:off x="9105900" y="3314700"/>
-            <a:ext cx="609600" cy="419100"/>
-          </a:xfrm>
-          <a:prstGeom prst="rect">
-            <a:avLst/>
-          </a:prstGeom>
-          <a:noFill/>
-        </p:spPr>
-        <p:txBody>
-          <a:bodyPr wrap="square" lIns="0" rIns="0" tIns="0" bIns="0">
+            <a:off x="9105900" y="3209925"/>
+            <a:ext cx="609600" cy="609600"/>
+          </a:xfrm>
+          <a:prstGeom prst="rect">
+            <a:avLst/>
+          </a:prstGeom>
+          <a:noFill/>
+        </p:spPr>
+        <p:txBody>
+          <a:bodyPr wrap="square" lIns="0" rIns="0" tIns="5334" bIns="0" anchor="ctr">
             <a:spAutoFit/>
           </a:bodyPr>
           <a:lstStyle/>
           <a:p>
             <a:pPr algn="ctr">
               <a:lnSpc>
-                <a:spcPct val="125000"/>
+                <a:spcPct val="100000"/>
               </a:lnSpc>
               <a:spcBef>
                 <a:spcPts val="0"/>

</xml_diff>

<commit_message>
Align dark slide bullet rows and finish visual audit
</commit_message>
<xml_diff>
--- a/brand/templates/dist/Dayova-Presentation.pptx
+++ b/brand/templates/dist/Dayova-Presentation.pptx
@@ -15297,7 +15297,7 @@
         </p:nvSpPr>
         <p:spPr>
           <a:xfrm>
-            <a:off x="1057275" y="3162300"/>
+            <a:off x="1057275" y="3000375"/>
             <a:ext cx="5048250" cy="561975"/>
           </a:xfrm>
           <a:prstGeom prst="rect">
@@ -15306,14 +15306,14 @@
           <a:noFill/>
         </p:spPr>
         <p:txBody>
-          <a:bodyPr wrap="square" lIns="0" rIns="0" tIns="0" bIns="0">
-            <a:spAutoFit/>
-          </a:bodyPr>
-          <a:lstStyle/>
-          <a:p>
-            <a:pPr algn="l">
-              <a:lnSpc>
-                <a:spcPct val="125000"/>
+          <a:bodyPr wrap="square" lIns="0" rIns="0" tIns="7200" bIns="0" anchor="ctr">
+            <a:spAutoFit/>
+          </a:bodyPr>
+          <a:lstStyle/>
+          <a:p>
+            <a:pPr algn="l">
+              <a:lnSpc>
+                <a:spcPct val="100000"/>
               </a:lnSpc>
               <a:spcBef>
                 <a:spcPts val="0"/>
@@ -15342,7 +15342,7 @@
         </p:nvSpPr>
         <p:spPr>
           <a:xfrm>
-            <a:off x="6286500" y="3209925"/>
+            <a:off x="6286500" y="3000375"/>
             <a:ext cx="5334000" cy="561975"/>
           </a:xfrm>
           <a:prstGeom prst="rect">
@@ -15351,14 +15351,14 @@
           <a:noFill/>
         </p:spPr>
         <p:txBody>
-          <a:bodyPr wrap="square" lIns="0" rIns="0" tIns="0" bIns="0">
-            <a:spAutoFit/>
-          </a:bodyPr>
-          <a:lstStyle/>
-          <a:p>
-            <a:pPr algn="l">
-              <a:lnSpc>
-                <a:spcPct val="125000"/>
+          <a:bodyPr wrap="square" lIns="0" rIns="0" tIns="0" bIns="7543" anchor="ctr">
+            <a:spAutoFit/>
+          </a:bodyPr>
+          <a:lstStyle/>
+          <a:p>
+            <a:pPr algn="l">
+              <a:lnSpc>
+                <a:spcPct val="100000"/>
               </a:lnSpc>
               <a:spcBef>
                 <a:spcPts val="0"/>
@@ -15430,7 +15430,7 @@
         </p:nvSpPr>
         <p:spPr>
           <a:xfrm>
-            <a:off x="1057275" y="4105274"/>
+            <a:off x="1057275" y="3943350"/>
             <a:ext cx="5048250" cy="561975"/>
           </a:xfrm>
           <a:prstGeom prst="rect">
@@ -15439,14 +15439,14 @@
           <a:noFill/>
         </p:spPr>
         <p:txBody>
-          <a:bodyPr wrap="square" lIns="0" rIns="0" tIns="0" bIns="0">
-            <a:spAutoFit/>
-          </a:bodyPr>
-          <a:lstStyle/>
-          <a:p>
-            <a:pPr algn="l">
-              <a:lnSpc>
-                <a:spcPct val="125000"/>
+          <a:bodyPr wrap="square" lIns="0" rIns="0" tIns="7200" bIns="0" anchor="ctr">
+            <a:spAutoFit/>
+          </a:bodyPr>
+          <a:lstStyle/>
+          <a:p>
+            <a:pPr algn="l">
+              <a:lnSpc>
+                <a:spcPct val="100000"/>
               </a:lnSpc>
               <a:spcBef>
                 <a:spcPts val="0"/>
@@ -15475,7 +15475,7 @@
         </p:nvSpPr>
         <p:spPr>
           <a:xfrm>
-            <a:off x="6286500" y="4152900"/>
+            <a:off x="6286500" y="3943350"/>
             <a:ext cx="5334000" cy="561975"/>
           </a:xfrm>
           <a:prstGeom prst="rect">
@@ -15484,14 +15484,14 @@
           <a:noFill/>
         </p:spPr>
         <p:txBody>
-          <a:bodyPr wrap="square" lIns="0" rIns="0" tIns="0" bIns="0">
-            <a:spAutoFit/>
-          </a:bodyPr>
-          <a:lstStyle/>
-          <a:p>
-            <a:pPr algn="l">
-              <a:lnSpc>
-                <a:spcPct val="125000"/>
+          <a:bodyPr wrap="square" lIns="0" rIns="0" tIns="0" bIns="7543" anchor="ctr">
+            <a:spAutoFit/>
+          </a:bodyPr>
+          <a:lstStyle/>
+          <a:p>
+            <a:pPr algn="l">
+              <a:lnSpc>
+                <a:spcPct val="100000"/>
               </a:lnSpc>
               <a:spcBef>
                 <a:spcPts val="0"/>
@@ -15563,7 +15563,7 @@
         </p:nvSpPr>
         <p:spPr>
           <a:xfrm>
-            <a:off x="1057275" y="5048250"/>
+            <a:off x="1057275" y="4886325"/>
             <a:ext cx="5048250" cy="561975"/>
           </a:xfrm>
           <a:prstGeom prst="rect">
@@ -15572,14 +15572,14 @@
           <a:noFill/>
         </p:spPr>
         <p:txBody>
-          <a:bodyPr wrap="square" lIns="0" rIns="0" tIns="0" bIns="0">
-            <a:spAutoFit/>
-          </a:bodyPr>
-          <a:lstStyle/>
-          <a:p>
-            <a:pPr algn="l">
-              <a:lnSpc>
-                <a:spcPct val="125000"/>
+          <a:bodyPr wrap="square" lIns="0" rIns="0" tIns="7200" bIns="0" anchor="ctr">
+            <a:spAutoFit/>
+          </a:bodyPr>
+          <a:lstStyle/>
+          <a:p>
+            <a:pPr algn="l">
+              <a:lnSpc>
+                <a:spcPct val="100000"/>
               </a:lnSpc>
               <a:spcBef>
                 <a:spcPts val="0"/>
@@ -15608,7 +15608,7 @@
         </p:nvSpPr>
         <p:spPr>
           <a:xfrm>
-            <a:off x="6286500" y="5095875"/>
+            <a:off x="6286500" y="4886325"/>
             <a:ext cx="5334000" cy="561975"/>
           </a:xfrm>
           <a:prstGeom prst="rect">
@@ -15617,14 +15617,14 @@
           <a:noFill/>
         </p:spPr>
         <p:txBody>
-          <a:bodyPr wrap="square" lIns="0" rIns="0" tIns="0" bIns="0">
-            <a:spAutoFit/>
-          </a:bodyPr>
-          <a:lstStyle/>
-          <a:p>
-            <a:pPr algn="l">
-              <a:lnSpc>
-                <a:spcPct val="125000"/>
+          <a:bodyPr wrap="square" lIns="0" rIns="0" tIns="0" bIns="7543" anchor="ctr">
+            <a:spAutoFit/>
+          </a:bodyPr>
+          <a:lstStyle/>
+          <a:p>
+            <a:pPr algn="l">
+              <a:lnSpc>
+                <a:spcPct val="100000"/>
               </a:lnSpc>
               <a:spcBef>
                 <a:spcPts val="0"/>

</xml_diff>

<commit_message>
Add original Dayova logo to template cover and start pages
</commit_message>
<xml_diff>
--- a/brand/templates/dist/Dayova-Presentation.pptx
+++ b/brand/templates/dist/Dayova-Presentation.pptx
@@ -689,7 +689,7 @@
           <a:lstStyle/>
           <a:p>
             <a:r>
-              <a:t>Titel durch maximal 7 Wörter ersetzen. Untertitel: ein Satz. Absender, Anlass und Datum ergänzen. Die abstrakte Route ist ein Kommunikationsmotiv, keine nachgebaute App-Oberfläche.</a:t>
+              <a:t>Titel durch maximal 7 Wörter ersetzen. Untertitel: ein Satz. Absender, Anlass und Datum ergänzen. Die abstrakte Route ist ein Kommunikationsmotiv, keine nachgebaute App-Oberfläche. Originales Dayova-Bildzeichen unverzerrt mit Wortmarke verwenden.</a:t>
             </a:r>
           </a:p>
         </p:txBody>
@@ -1319,7 +1319,7 @@
           <a:lstStyle/>
           <a:p>
             <a:r>
-              <a:t>Abschluss: eine konkrete Handlung, Person und Termin. Kontakt / Link vor Veröffentlichung prüfen.</a:t>
+              <a:t>Abschluss: eine konkrete Handlung, Person und Termin. Kontakt / Link vor Veröffentlichung prüfen. Originales Dayova-Bildzeichen unverzerrt mit Wortmarke verwenden.</a:t>
             </a:r>
           </a:p>
         </p:txBody>
@@ -5033,31 +5033,55 @@
         <p:nvPr/>
       </p:nvGrpSpPr>
       <p:grpSpPr/>
-      <p:sp>
-        <p:nvSpPr>
-          <p:cNvPr id="2" name="dayova."/>
-          <p:cNvSpPr txBox="1"/>
-          <p:nvPr/>
-        </p:nvSpPr>
-        <p:spPr>
-          <a:xfrm>
-            <a:off x="533400" y="304800"/>
-            <a:ext cx="1905000" cy="400050"/>
-          </a:xfrm>
-          <a:prstGeom prst="rect">
-            <a:avLst/>
-          </a:prstGeom>
-          <a:noFill/>
-        </p:spPr>
-        <p:txBody>
-          <a:bodyPr wrap="square" lIns="0" rIns="0" tIns="0" bIns="0">
-            <a:spAutoFit/>
-          </a:bodyPr>
-          <a:lstStyle/>
-          <a:p>
-            <a:pPr algn="l">
-              <a:lnSpc>
-                <a:spcPct val="125000"/>
+      <p:pic>
+        <p:nvPicPr>
+          <p:cNvPr id="2" name="Picture 1" descr="Dayova – originales Bildzeichen"/>
+          <p:cNvPicPr>
+            <a:picLocks noChangeAspect="1"/>
+          </p:cNvPicPr>
+          <p:nvPr/>
+        </p:nvPicPr>
+        <p:blipFill>
+          <a:blip r:embed="rId3"/>
+          <a:stretch>
+            <a:fillRect/>
+          </a:stretch>
+        </p:blipFill>
+        <p:spPr>
+          <a:xfrm>
+            <a:off x="381000" y="114300"/>
+            <a:ext cx="762000" cy="762000"/>
+          </a:xfrm>
+          <a:prstGeom prst="rect">
+            <a:avLst/>
+          </a:prstGeom>
+        </p:spPr>
+      </p:pic>
+      <p:sp>
+        <p:nvSpPr>
+          <p:cNvPr id="3" name="dayova."/>
+          <p:cNvSpPr txBox="1"/>
+          <p:nvPr/>
+        </p:nvSpPr>
+        <p:spPr>
+          <a:xfrm>
+            <a:off x="1162050" y="114300"/>
+            <a:ext cx="1905000" cy="762000"/>
+          </a:xfrm>
+          <a:prstGeom prst="rect">
+            <a:avLst/>
+          </a:prstGeom>
+          <a:noFill/>
+        </p:spPr>
+        <p:txBody>
+          <a:bodyPr wrap="square" lIns="0" rIns="0" tIns="0" bIns="59207" anchor="ctr">
+            <a:spAutoFit/>
+          </a:bodyPr>
+          <a:lstStyle/>
+          <a:p>
+            <a:pPr algn="l">
+              <a:lnSpc>
+                <a:spcPct val="100000"/>
               </a:lnSpc>
               <a:spcBef>
                 <a:spcPts val="0"/>
@@ -5080,7 +5104,7 @@
       </p:sp>
       <p:sp>
         <p:nvSpPr>
-          <p:cNvPr id="3" name="TITEL"/>
+          <p:cNvPr id="4" name="TITEL"/>
           <p:cNvSpPr txBox="1"/>
           <p:nvPr/>
         </p:nvSpPr>
@@ -5125,7 +5149,7 @@
       </p:sp>
       <p:sp>
         <p:nvSpPr>
-          <p:cNvPr id="4" name="Text"/>
+          <p:cNvPr id="5" name="Text"/>
           <p:cNvSpPr/>
           <p:nvPr/>
         </p:nvSpPr>
@@ -5168,7 +5192,7 @@
       </p:sp>
       <p:sp>
         <p:nvSpPr>
-          <p:cNvPr id="5" name="DAYOVA  /  VORLAGEN · 2026"/>
+          <p:cNvPr id="6" name="DAYOVA  /  VORLAGEN · 2026"/>
           <p:cNvSpPr txBox="1"/>
           <p:nvPr/>
         </p:nvSpPr>
@@ -5213,7 +5237,7 @@
       </p:sp>
       <p:sp>
         <p:nvSpPr>
-          <p:cNvPr id="6" name="01"/>
+          <p:cNvPr id="7" name="01"/>
           <p:cNvSpPr txBox="1"/>
           <p:nvPr/>
         </p:nvSpPr>
@@ -5258,7 +5282,7 @@
       </p:sp>
       <p:sp>
         <p:nvSpPr>
-          <p:cNvPr id="7" name="Text"/>
+          <p:cNvPr id="8" name="Text"/>
           <p:cNvSpPr/>
           <p:nvPr/>
         </p:nvSpPr>
@@ -5303,7 +5327,7 @@
       </p:sp>
       <p:sp>
         <p:nvSpPr>
-          <p:cNvPr id="8" name="Einfach&#10;loslernen."/>
+          <p:cNvPr id="9" name="Einfach&#10;loslernen."/>
           <p:cNvSpPr txBox="1"/>
           <p:nvPr/>
         </p:nvSpPr>
@@ -5370,7 +5394,7 @@
       </p:sp>
       <p:sp>
         <p:nvSpPr>
-          <p:cNvPr id="9" name="Der Plan steht schon."/>
+          <p:cNvPr id="10" name="Der Plan steht schon."/>
           <p:cNvSpPr txBox="1"/>
           <p:nvPr/>
         </p:nvSpPr>
@@ -5415,7 +5439,7 @@
       </p:sp>
       <p:sp>
         <p:nvSpPr>
-          <p:cNvPr id="10" name="[Anlass / Präsentation]&#10;[Name] · [Datum]"/>
+          <p:cNvPr id="11" name="[Anlass / Präsentation]&#10;[Name] · [Datum]"/>
           <p:cNvSpPr txBox="1"/>
           <p:nvPr/>
         </p:nvSpPr>
@@ -5482,7 +5506,7 @@
       </p:sp>
       <p:sp>
         <p:nvSpPr>
-          <p:cNvPr id="11" name="Text"/>
+          <p:cNvPr id="12" name="Text"/>
           <p:cNvSpPr/>
           <p:nvPr/>
         </p:nvSpPr>
@@ -5527,7 +5551,7 @@
       </p:sp>
       <p:sp>
         <p:nvSpPr>
-          <p:cNvPr id="12" name="Text"/>
+          <p:cNvPr id="13" name="Text"/>
           <p:cNvSpPr/>
           <p:nvPr/>
         </p:nvSpPr>
@@ -5572,7 +5596,7 @@
       </p:sp>
       <p:sp>
         <p:nvSpPr>
-          <p:cNvPr id="13" name="Text"/>
+          <p:cNvPr id="14" name="Text"/>
           <p:cNvSpPr/>
           <p:nvPr/>
         </p:nvSpPr>
@@ -5617,7 +5641,7 @@
       </p:sp>
       <p:sp>
         <p:nvSpPr>
-          <p:cNvPr id="14" name="Text"/>
+          <p:cNvPr id="15" name="Text"/>
           <p:cNvSpPr/>
           <p:nvPr/>
         </p:nvSpPr>
@@ -5662,7 +5686,7 @@
       </p:sp>
       <p:sp>
         <p:nvSpPr>
-          <p:cNvPr id="15" name="Text"/>
+          <p:cNvPr id="16" name="Text"/>
           <p:cNvSpPr/>
           <p:nvPr/>
         </p:nvSpPr>
@@ -5707,7 +5731,7 @@
       </p:sp>
       <p:sp>
         <p:nvSpPr>
-          <p:cNvPr id="16" name="Text"/>
+          <p:cNvPr id="17" name="Text"/>
           <p:cNvSpPr/>
           <p:nvPr/>
         </p:nvSpPr>
@@ -5752,7 +5776,7 @@
       </p:sp>
       <p:sp>
         <p:nvSpPr>
-          <p:cNvPr id="17" name="Text"/>
+          <p:cNvPr id="18" name="Text"/>
           <p:cNvSpPr/>
           <p:nvPr/>
         </p:nvSpPr>
@@ -5797,7 +5821,7 @@
       </p:sp>
       <p:sp>
         <p:nvSpPr>
-          <p:cNvPr id="18" name="Text"/>
+          <p:cNvPr id="19" name="Text"/>
           <p:cNvSpPr/>
           <p:nvPr/>
         </p:nvSpPr>
@@ -5842,7 +5866,7 @@
       </p:sp>
       <p:sp>
         <p:nvSpPr>
-          <p:cNvPr id="19" name="Text"/>
+          <p:cNvPr id="20" name="Text"/>
           <p:cNvSpPr/>
           <p:nvPr/>
         </p:nvSpPr>
@@ -5887,7 +5911,7 @@
       </p:sp>
       <p:sp>
         <p:nvSpPr>
-          <p:cNvPr id="20" name="Text"/>
+          <p:cNvPr id="21" name="Text"/>
           <p:cNvSpPr/>
           <p:nvPr/>
         </p:nvSpPr>
@@ -5930,7 +5954,7 @@
       </p:sp>
       <p:sp>
         <p:nvSpPr>
-          <p:cNvPr id="21" name="01"/>
+          <p:cNvPr id="22" name="01"/>
           <p:cNvSpPr txBox="1"/>
           <p:nvPr/>
         </p:nvSpPr>
@@ -5975,7 +5999,7 @@
       </p:sp>
       <p:sp>
         <p:nvSpPr>
-          <p:cNvPr id="22" name="Text"/>
+          <p:cNvPr id="23" name="Text"/>
           <p:cNvSpPr/>
           <p:nvPr/>
         </p:nvSpPr>
@@ -6018,7 +6042,7 @@
       </p:sp>
       <p:sp>
         <p:nvSpPr>
-          <p:cNvPr id="23" name="02"/>
+          <p:cNvPr id="24" name="02"/>
           <p:cNvSpPr txBox="1"/>
           <p:nvPr/>
         </p:nvSpPr>
@@ -6063,7 +6087,7 @@
       </p:sp>
       <p:sp>
         <p:nvSpPr>
-          <p:cNvPr id="24" name="Text"/>
+          <p:cNvPr id="25" name="Text"/>
           <p:cNvSpPr/>
           <p:nvPr/>
         </p:nvSpPr>
@@ -6106,7 +6130,7 @@
       </p:sp>
       <p:sp>
         <p:nvSpPr>
-          <p:cNvPr id="25" name="03"/>
+          <p:cNvPr id="26" name="03"/>
           <p:cNvSpPr txBox="1"/>
           <p:nvPr/>
         </p:nvSpPr>
@@ -6151,7 +6175,7 @@
       </p:sp>
       <p:sp>
         <p:nvSpPr>
-          <p:cNvPr id="26" name="Text"/>
+          <p:cNvPr id="27" name="Text"/>
           <p:cNvSpPr/>
           <p:nvPr/>
         </p:nvSpPr>
@@ -6194,7 +6218,7 @@
       </p:sp>
       <p:sp>
         <p:nvSpPr>
-          <p:cNvPr id="27" name="04"/>
+          <p:cNvPr id="28" name="04"/>
           <p:cNvSpPr txBox="1"/>
           <p:nvPr/>
         </p:nvSpPr>
@@ -6239,7 +6263,7 @@
       </p:sp>
       <p:sp>
         <p:nvSpPr>
-          <p:cNvPr id="28" name="SCHRITT FÜR SCHRITT"/>
+          <p:cNvPr id="29" name="SCHRITT FÜR SCHRITT"/>
           <p:cNvSpPr txBox="1"/>
           <p:nvPr/>
         </p:nvSpPr>
@@ -12409,31 +12433,55 @@
         <p:nvPr/>
       </p:nvGrpSpPr>
       <p:grpSpPr/>
-      <p:sp>
-        <p:nvSpPr>
-          <p:cNvPr id="2" name="dayova."/>
-          <p:cNvSpPr txBox="1"/>
-          <p:nvPr/>
-        </p:nvSpPr>
-        <p:spPr>
-          <a:xfrm>
-            <a:off x="533400" y="304800"/>
-            <a:ext cx="1905000" cy="400050"/>
-          </a:xfrm>
-          <a:prstGeom prst="rect">
-            <a:avLst/>
-          </a:prstGeom>
-          <a:noFill/>
-        </p:spPr>
-        <p:txBody>
-          <a:bodyPr wrap="square" lIns="0" rIns="0" tIns="0" bIns="0">
-            <a:spAutoFit/>
-          </a:bodyPr>
-          <a:lstStyle/>
-          <a:p>
-            <a:pPr algn="l">
-              <a:lnSpc>
-                <a:spcPct val="125000"/>
+      <p:pic>
+        <p:nvPicPr>
+          <p:cNvPr id="2" name="Picture 1" descr="Dayova – originales Bildzeichen"/>
+          <p:cNvPicPr>
+            <a:picLocks noChangeAspect="1"/>
+          </p:cNvPicPr>
+          <p:nvPr/>
+        </p:nvPicPr>
+        <p:blipFill>
+          <a:blip r:embed="rId3"/>
+          <a:stretch>
+            <a:fillRect/>
+          </a:stretch>
+        </p:blipFill>
+        <p:spPr>
+          <a:xfrm>
+            <a:off x="381000" y="114300"/>
+            <a:ext cx="762000" cy="762000"/>
+          </a:xfrm>
+          <a:prstGeom prst="rect">
+            <a:avLst/>
+          </a:prstGeom>
+        </p:spPr>
+      </p:pic>
+      <p:sp>
+        <p:nvSpPr>
+          <p:cNvPr id="3" name="dayova."/>
+          <p:cNvSpPr txBox="1"/>
+          <p:nvPr/>
+        </p:nvSpPr>
+        <p:spPr>
+          <a:xfrm>
+            <a:off x="1162050" y="114300"/>
+            <a:ext cx="1905000" cy="762000"/>
+          </a:xfrm>
+          <a:prstGeom prst="rect">
+            <a:avLst/>
+          </a:prstGeom>
+          <a:noFill/>
+        </p:spPr>
+        <p:txBody>
+          <a:bodyPr wrap="square" lIns="0" rIns="0" tIns="0" bIns="59207" anchor="ctr">
+            <a:spAutoFit/>
+          </a:bodyPr>
+          <a:lstStyle/>
+          <a:p>
+            <a:pPr algn="l">
+              <a:lnSpc>
+                <a:spcPct val="100000"/>
               </a:lnSpc>
               <a:spcBef>
                 <a:spcPts val="0"/>
@@ -12456,7 +12504,7 @@
       </p:sp>
       <p:sp>
         <p:nvSpPr>
-          <p:cNvPr id="3" name="ABSCHLUSS"/>
+          <p:cNvPr id="4" name="ABSCHLUSS"/>
           <p:cNvSpPr txBox="1"/>
           <p:nvPr/>
         </p:nvSpPr>
@@ -12501,7 +12549,7 @@
       </p:sp>
       <p:sp>
         <p:nvSpPr>
-          <p:cNvPr id="4" name="Text"/>
+          <p:cNvPr id="5" name="Text"/>
           <p:cNvSpPr/>
           <p:nvPr/>
         </p:nvSpPr>
@@ -12544,7 +12592,7 @@
       </p:sp>
       <p:sp>
         <p:nvSpPr>
-          <p:cNvPr id="5" name="DAYOVA  /  VORLAGEN · 2026"/>
+          <p:cNvPr id="6" name="DAYOVA  /  VORLAGEN · 2026"/>
           <p:cNvSpPr txBox="1"/>
           <p:nvPr/>
         </p:nvSpPr>
@@ -12589,7 +12637,7 @@
       </p:sp>
       <p:sp>
         <p:nvSpPr>
-          <p:cNvPr id="6" name="18"/>
+          <p:cNvPr id="7" name="18"/>
           <p:cNvSpPr txBox="1"/>
           <p:nvPr/>
         </p:nvSpPr>
@@ -12634,7 +12682,7 @@
       </p:sp>
       <p:sp>
         <p:nvSpPr>
-          <p:cNvPr id="7" name="Text"/>
+          <p:cNvPr id="8" name="Text"/>
           <p:cNvSpPr/>
           <p:nvPr/>
         </p:nvSpPr>
@@ -12679,7 +12727,7 @@
       </p:sp>
       <p:sp>
         <p:nvSpPr>
-          <p:cNvPr id="8" name="Was ist unser&#10;nächster Schritt?"/>
+          <p:cNvPr id="9" name="Was ist unser&#10;nächster Schritt?"/>
           <p:cNvSpPr txBox="1"/>
           <p:nvPr/>
         </p:nvSpPr>
@@ -12746,7 +12794,7 @@
       </p:sp>
       <p:sp>
         <p:nvSpPr>
-          <p:cNvPr id="9" name="[Konkrete Handlung]  ·  [Name]  ·  [Termin]"/>
+          <p:cNvPr id="10" name="[Konkrete Handlung]  ·  [Name]  ·  [Termin]"/>
           <p:cNvSpPr txBox="1"/>
           <p:nvPr/>
         </p:nvSpPr>
@@ -12791,7 +12839,7 @@
       </p:sp>
       <p:sp>
         <p:nvSpPr>
-          <p:cNvPr id="10" name="Text"/>
+          <p:cNvPr id="11" name="Text"/>
           <p:cNvSpPr/>
           <p:nvPr/>
         </p:nvSpPr>
@@ -12836,7 +12884,7 @@
       </p:sp>
       <p:sp>
         <p:nvSpPr>
-          <p:cNvPr id="11" name="[Aktion benennen]"/>
+          <p:cNvPr id="12" name="[Aktion benennen]"/>
           <p:cNvSpPr txBox="1"/>
           <p:nvPr/>
         </p:nvSpPr>
@@ -12881,7 +12929,7 @@
       </p:sp>
       <p:sp>
         <p:nvSpPr>
-          <p:cNvPr id="12" name="dayova.com"/>
+          <p:cNvPr id="13" name="dayova.com"/>
           <p:cNvSpPr txBox="1"/>
           <p:nvPr/>
         </p:nvSpPr>
@@ -21113,7 +21161,7 @@
       </p:sp>
       <p:pic>
         <p:nvPicPr>
-          <p:cNvPr id="11" name="Picture 10" descr="android-light-intro-daily-guidance-shared.png"/>
+          <p:cNvPr id="11" name="Picture 10" descr="Dayova App – aufgezeichneter Onboarding-Zustand"/>
           <p:cNvPicPr>
             <a:picLocks noChangeAspect="1"/>
           </p:cNvPicPr>

</xml_diff>

<commit_message>
Replace cover staircase with authentic native learning path
</commit_message>
<xml_diff>
--- a/brand/templates/dist/Dayova-Presentation.pptx
+++ b/brand/templates/dist/Dayova-Presentation.pptx
@@ -689,7 +689,7 @@
           <a:lstStyle/>
           <a:p>
             <a:r>
-              <a:t>Titel durch maximal 7 Wörter ersetzen. Untertitel: ein Satz. Absender, Anlass und Datum ergänzen. Die abstrakte Route ist ein Kommunikationsmotiv, keine nachgebaute App-Oberfläche. Originales Dayova-Bildzeichen unverzerrt mit Wortmarke verwenden.</a:t>
+              <a:t>Titel durch maximal 7 Wörter ersetzen. Untertitel: ein Satz. Absender, Anlass und Datum ergänzen. Lernpfad: unveränderter Ausschnitt der nativen Android-Aufnahme android-light-intro-learning-path-settled.png vom 30.08.2026, LearningPathVisual, Quellcommit c576928. Erledigt blau; aktueller Schritt grau mit Auswahlring; weitere Vorschau grau. Keine frisch aufgenommene App-Ansicht. Bei Änderungen am Produkt neu exportieren, nicht nachzeichnen. Originales Dayova-Bildzeichen unverzerrt mit Wortmarke verwenden.</a:t>
             </a:r>
           </a:p>
         </p:txBody>
@@ -5297,7 +5297,7 @@
             </a:avLst>
           </a:prstGeom>
           <a:solidFill>
-            <a:srgbClr val="00BAFF"/>
+            <a:srgbClr val="F1F7FB"/>
           </a:solidFill>
           <a:ln>
             <a:noFill/>
@@ -5325,9 +5325,33 @@
           </a:p>
         </p:txBody>
       </p:sp>
-      <p:sp>
-        <p:nvSpPr>
-          <p:cNvPr id="9" name="Einfach&#10;loslernen."/>
+      <p:pic>
+        <p:nvPicPr>
+          <p:cNvPr id="9" name="Picture 8" descr="Dayova Lernpfad: erledigter Schritt, ausgewählter nächster Schritt und adaptive Vorschau. Nativer Bildausschnitt vom 30.08.2026."/>
+          <p:cNvPicPr>
+            <a:picLocks noChangeAspect="1"/>
+          </p:cNvPicPr>
+          <p:nvPr/>
+        </p:nvPicPr>
+        <p:blipFill>
+          <a:blip r:embed="rId4"/>
+          <a:stretch>
+            <a:fillRect/>
+          </a:stretch>
+        </p:blipFill>
+        <p:spPr>
+          <a:xfrm>
+            <a:off x="8039099" y="1228725"/>
+            <a:ext cx="3352800" cy="4577861"/>
+          </a:xfrm>
+          <a:prstGeom prst="rect">
+            <a:avLst/>
+          </a:prstGeom>
+        </p:spPr>
+      </p:pic>
+      <p:sp>
+        <p:nvSpPr>
+          <p:cNvPr id="10" name="Einfach&#10;loslernen."/>
           <p:cNvSpPr txBox="1"/>
           <p:nvPr/>
         </p:nvSpPr>
@@ -5394,7 +5418,7 @@
       </p:sp>
       <p:sp>
         <p:nvSpPr>
-          <p:cNvPr id="10" name="Der Plan steht schon."/>
+          <p:cNvPr id="11" name="Der Plan steht schon."/>
           <p:cNvSpPr txBox="1"/>
           <p:nvPr/>
         </p:nvSpPr>
@@ -5439,7 +5463,7 @@
       </p:sp>
       <p:sp>
         <p:nvSpPr>
-          <p:cNvPr id="11" name="[Anlass / Präsentation]&#10;[Name] · [Datum]"/>
+          <p:cNvPr id="12" name="[Anlass / Präsentation]&#10;[Name] · [Datum]"/>
           <p:cNvSpPr txBox="1"/>
           <p:nvPr/>
         </p:nvSpPr>
@@ -5500,808 +5524,6 @@
             </a:pPr>
             <a:r>
               <a:t>[Name] · [Datum]</a:t>
-            </a:r>
-          </a:p>
-        </p:txBody>
-      </p:sp>
-      <p:sp>
-        <p:nvSpPr>
-          <p:cNvPr id="12" name="Text"/>
-          <p:cNvSpPr/>
-          <p:nvPr/>
-        </p:nvSpPr>
-        <p:spPr>
-          <a:xfrm>
-            <a:off x="8782050" y="4419600"/>
-            <a:ext cx="38100" cy="457200"/>
-          </a:xfrm>
-          <a:prstGeom prst="roundRect">
-            <a:avLst>
-              <a:gd name="adj" fmla="val 50000"/>
-            </a:avLst>
-          </a:prstGeom>
-          <a:solidFill>
-            <a:srgbClr val="1A1A1A"/>
-          </a:solidFill>
-          <a:ln>
-            <a:noFill/>
-          </a:ln>
-        </p:spPr>
-        <p:style>
-          <a:lnRef idx="1">
-            <a:schemeClr val="accent1"/>
-          </a:lnRef>
-          <a:fillRef idx="3">
-            <a:schemeClr val="accent1"/>
-          </a:fillRef>
-          <a:effectRef idx="2">
-            <a:schemeClr val="accent1"/>
-          </a:effectRef>
-          <a:fontRef idx="minor">
-            <a:schemeClr val="lt1"/>
-          </a:fontRef>
-        </p:style>
-        <p:txBody>
-          <a:bodyPr rtlCol="0" anchor="ctr"/>
-          <a:lstStyle/>
-          <a:p>
-            <a:pPr algn="ctr"/>
-          </a:p>
-        </p:txBody>
-      </p:sp>
-      <p:sp>
-        <p:nvSpPr>
-          <p:cNvPr id="13" name="Text"/>
-          <p:cNvSpPr/>
-          <p:nvPr/>
-        </p:nvSpPr>
-        <p:spPr>
-          <a:xfrm>
-            <a:off x="8801100" y="4400550"/>
-            <a:ext cx="1724025" cy="38100"/>
-          </a:xfrm>
-          <a:prstGeom prst="roundRect">
-            <a:avLst>
-              <a:gd name="adj" fmla="val 50000"/>
-            </a:avLst>
-          </a:prstGeom>
-          <a:solidFill>
-            <a:srgbClr val="1A1A1A"/>
-          </a:solidFill>
-          <a:ln>
-            <a:noFill/>
-          </a:ln>
-        </p:spPr>
-        <p:style>
-          <a:lnRef idx="1">
-            <a:schemeClr val="accent1"/>
-          </a:lnRef>
-          <a:fillRef idx="3">
-            <a:schemeClr val="accent1"/>
-          </a:fillRef>
-          <a:effectRef idx="2">
-            <a:schemeClr val="accent1"/>
-          </a:effectRef>
-          <a:fontRef idx="minor">
-            <a:schemeClr val="lt1"/>
-          </a:fontRef>
-        </p:style>
-        <p:txBody>
-          <a:bodyPr rtlCol="0" anchor="ctr"/>
-          <a:lstStyle/>
-          <a:p>
-            <a:pPr algn="ctr"/>
-          </a:p>
-        </p:txBody>
-      </p:sp>
-      <p:sp>
-        <p:nvSpPr>
-          <p:cNvPr id="14" name="Text"/>
-          <p:cNvSpPr/>
-          <p:nvPr/>
-        </p:nvSpPr>
-        <p:spPr>
-          <a:xfrm>
-            <a:off x="10506075" y="3962399"/>
-            <a:ext cx="38100" cy="457200"/>
-          </a:xfrm>
-          <a:prstGeom prst="roundRect">
-            <a:avLst>
-              <a:gd name="adj" fmla="val 50000"/>
-            </a:avLst>
-          </a:prstGeom>
-          <a:solidFill>
-            <a:srgbClr val="1A1A1A"/>
-          </a:solidFill>
-          <a:ln>
-            <a:noFill/>
-          </a:ln>
-        </p:spPr>
-        <p:style>
-          <a:lnRef idx="1">
-            <a:schemeClr val="accent1"/>
-          </a:lnRef>
-          <a:fillRef idx="3">
-            <a:schemeClr val="accent1"/>
-          </a:fillRef>
-          <a:effectRef idx="2">
-            <a:schemeClr val="accent1"/>
-          </a:effectRef>
-          <a:fontRef idx="minor">
-            <a:schemeClr val="lt1"/>
-          </a:fontRef>
-        </p:style>
-        <p:txBody>
-          <a:bodyPr rtlCol="0" anchor="ctr"/>
-          <a:lstStyle/>
-          <a:p>
-            <a:pPr algn="ctr"/>
-          </a:p>
-        </p:txBody>
-      </p:sp>
-      <p:sp>
-        <p:nvSpPr>
-          <p:cNvPr id="15" name="Text"/>
-          <p:cNvSpPr/>
-          <p:nvPr/>
-        </p:nvSpPr>
-        <p:spPr>
-          <a:xfrm>
-            <a:off x="10506075" y="3424237"/>
-            <a:ext cx="38100" cy="538162"/>
-          </a:xfrm>
-          <a:prstGeom prst="roundRect">
-            <a:avLst>
-              <a:gd name="adj" fmla="val 50000"/>
-            </a:avLst>
-          </a:prstGeom>
-          <a:solidFill>
-            <a:srgbClr val="1A1A1A"/>
-          </a:solidFill>
-          <a:ln>
-            <a:noFill/>
-          </a:ln>
-        </p:spPr>
-        <p:style>
-          <a:lnRef idx="1">
-            <a:schemeClr val="accent1"/>
-          </a:lnRef>
-          <a:fillRef idx="3">
-            <a:schemeClr val="accent1"/>
-          </a:fillRef>
-          <a:effectRef idx="2">
-            <a:schemeClr val="accent1"/>
-          </a:effectRef>
-          <a:fontRef idx="minor">
-            <a:schemeClr val="lt1"/>
-          </a:fontRef>
-        </p:style>
-        <p:txBody>
-          <a:bodyPr rtlCol="0" anchor="ctr"/>
-          <a:lstStyle/>
-          <a:p>
-            <a:pPr algn="ctr"/>
-          </a:p>
-        </p:txBody>
-      </p:sp>
-      <p:sp>
-        <p:nvSpPr>
-          <p:cNvPr id="16" name="Text"/>
-          <p:cNvSpPr/>
-          <p:nvPr/>
-        </p:nvSpPr>
-        <p:spPr>
-          <a:xfrm>
-            <a:off x="8963025" y="3405187"/>
-            <a:ext cx="1562100" cy="38100"/>
-          </a:xfrm>
-          <a:prstGeom prst="roundRect">
-            <a:avLst>
-              <a:gd name="adj" fmla="val 50000"/>
-            </a:avLst>
-          </a:prstGeom>
-          <a:solidFill>
-            <a:srgbClr val="1A1A1A"/>
-          </a:solidFill>
-          <a:ln>
-            <a:noFill/>
-          </a:ln>
-        </p:spPr>
-        <p:style>
-          <a:lnRef idx="1">
-            <a:schemeClr val="accent1"/>
-          </a:lnRef>
-          <a:fillRef idx="3">
-            <a:schemeClr val="accent1"/>
-          </a:fillRef>
-          <a:effectRef idx="2">
-            <a:schemeClr val="accent1"/>
-          </a:effectRef>
-          <a:fontRef idx="minor">
-            <a:schemeClr val="lt1"/>
-          </a:fontRef>
-        </p:style>
-        <p:txBody>
-          <a:bodyPr rtlCol="0" anchor="ctr"/>
-          <a:lstStyle/>
-          <a:p>
-            <a:pPr algn="ctr"/>
-          </a:p>
-        </p:txBody>
-      </p:sp>
-      <p:sp>
-        <p:nvSpPr>
-          <p:cNvPr id="17" name="Text"/>
-          <p:cNvSpPr/>
-          <p:nvPr/>
-        </p:nvSpPr>
-        <p:spPr>
-          <a:xfrm>
-            <a:off x="8943975" y="2886075"/>
-            <a:ext cx="38100" cy="538162"/>
-          </a:xfrm>
-          <a:prstGeom prst="roundRect">
-            <a:avLst>
-              <a:gd name="adj" fmla="val 50000"/>
-            </a:avLst>
-          </a:prstGeom>
-          <a:solidFill>
-            <a:srgbClr val="1A1A1A"/>
-          </a:solidFill>
-          <a:ln>
-            <a:noFill/>
-          </a:ln>
-        </p:spPr>
-        <p:style>
-          <a:lnRef idx="1">
-            <a:schemeClr val="accent1"/>
-          </a:lnRef>
-          <a:fillRef idx="3">
-            <a:schemeClr val="accent1"/>
-          </a:fillRef>
-          <a:effectRef idx="2">
-            <a:schemeClr val="accent1"/>
-          </a:effectRef>
-          <a:fontRef idx="minor">
-            <a:schemeClr val="lt1"/>
-          </a:fontRef>
-        </p:style>
-        <p:txBody>
-          <a:bodyPr rtlCol="0" anchor="ctr"/>
-          <a:lstStyle/>
-          <a:p>
-            <a:pPr algn="ctr"/>
-          </a:p>
-        </p:txBody>
-      </p:sp>
-      <p:sp>
-        <p:nvSpPr>
-          <p:cNvPr id="18" name="Text"/>
-          <p:cNvSpPr/>
-          <p:nvPr/>
-        </p:nvSpPr>
-        <p:spPr>
-          <a:xfrm>
-            <a:off x="8943975" y="2471737"/>
-            <a:ext cx="38100" cy="414337"/>
-          </a:xfrm>
-          <a:prstGeom prst="roundRect">
-            <a:avLst>
-              <a:gd name="adj" fmla="val 50000"/>
-            </a:avLst>
-          </a:prstGeom>
-          <a:solidFill>
-            <a:srgbClr val="1A1A1A"/>
-          </a:solidFill>
-          <a:ln>
-            <a:noFill/>
-          </a:ln>
-        </p:spPr>
-        <p:style>
-          <a:lnRef idx="1">
-            <a:schemeClr val="accent1"/>
-          </a:lnRef>
-          <a:fillRef idx="3">
-            <a:schemeClr val="accent1"/>
-          </a:fillRef>
-          <a:effectRef idx="2">
-            <a:schemeClr val="accent1"/>
-          </a:effectRef>
-          <a:fontRef idx="minor">
-            <a:schemeClr val="lt1"/>
-          </a:fontRef>
-        </p:style>
-        <p:txBody>
-          <a:bodyPr rtlCol="0" anchor="ctr"/>
-          <a:lstStyle/>
-          <a:p>
-            <a:pPr algn="ctr"/>
-          </a:p>
-        </p:txBody>
-      </p:sp>
-      <p:sp>
-        <p:nvSpPr>
-          <p:cNvPr id="19" name="Text"/>
-          <p:cNvSpPr/>
-          <p:nvPr/>
-        </p:nvSpPr>
-        <p:spPr>
-          <a:xfrm>
-            <a:off x="8963025" y="2452687"/>
-            <a:ext cx="1562100" cy="38100"/>
-          </a:xfrm>
-          <a:prstGeom prst="roundRect">
-            <a:avLst>
-              <a:gd name="adj" fmla="val 50000"/>
-            </a:avLst>
-          </a:prstGeom>
-          <a:solidFill>
-            <a:srgbClr val="1A1A1A"/>
-          </a:solidFill>
-          <a:ln>
-            <a:noFill/>
-          </a:ln>
-        </p:spPr>
-        <p:style>
-          <a:lnRef idx="1">
-            <a:schemeClr val="accent1"/>
-          </a:lnRef>
-          <a:fillRef idx="3">
-            <a:schemeClr val="accent1"/>
-          </a:fillRef>
-          <a:effectRef idx="2">
-            <a:schemeClr val="accent1"/>
-          </a:effectRef>
-          <a:fontRef idx="minor">
-            <a:schemeClr val="lt1"/>
-          </a:fontRef>
-        </p:style>
-        <p:txBody>
-          <a:bodyPr rtlCol="0" anchor="ctr"/>
-          <a:lstStyle/>
-          <a:p>
-            <a:pPr algn="ctr"/>
-          </a:p>
-        </p:txBody>
-      </p:sp>
-      <p:sp>
-        <p:nvSpPr>
-          <p:cNvPr id="20" name="Text"/>
-          <p:cNvSpPr/>
-          <p:nvPr/>
-        </p:nvSpPr>
-        <p:spPr>
-          <a:xfrm>
-            <a:off x="10506075" y="2057400"/>
-            <a:ext cx="38100" cy="414337"/>
-          </a:xfrm>
-          <a:prstGeom prst="roundRect">
-            <a:avLst>
-              <a:gd name="adj" fmla="val 50000"/>
-            </a:avLst>
-          </a:prstGeom>
-          <a:solidFill>
-            <a:srgbClr val="1A1A1A"/>
-          </a:solidFill>
-          <a:ln>
-            <a:noFill/>
-          </a:ln>
-        </p:spPr>
-        <p:style>
-          <a:lnRef idx="1">
-            <a:schemeClr val="accent1"/>
-          </a:lnRef>
-          <a:fillRef idx="3">
-            <a:schemeClr val="accent1"/>
-          </a:fillRef>
-          <a:effectRef idx="2">
-            <a:schemeClr val="accent1"/>
-          </a:effectRef>
-          <a:fontRef idx="minor">
-            <a:schemeClr val="lt1"/>
-          </a:fontRef>
-        </p:style>
-        <p:txBody>
-          <a:bodyPr rtlCol="0" anchor="ctr"/>
-          <a:lstStyle/>
-          <a:p>
-            <a:pPr algn="ctr"/>
-          </a:p>
-        </p:txBody>
-      </p:sp>
-      <p:sp>
-        <p:nvSpPr>
-          <p:cNvPr id="21" name="Text"/>
-          <p:cNvSpPr/>
-          <p:nvPr/>
-        </p:nvSpPr>
-        <p:spPr>
-          <a:xfrm>
-            <a:off x="8467725" y="4543425"/>
-            <a:ext cx="666750" cy="666750"/>
-          </a:xfrm>
-          <a:prstGeom prst="ellipse">
-            <a:avLst/>
-          </a:prstGeom>
-          <a:solidFill>
-            <a:srgbClr val="1A1A1A"/>
-          </a:solidFill>
-          <a:ln>
-            <a:noFill/>
-          </a:ln>
-        </p:spPr>
-        <p:style>
-          <a:lnRef idx="1">
-            <a:schemeClr val="accent1"/>
-          </a:lnRef>
-          <a:fillRef idx="3">
-            <a:schemeClr val="accent1"/>
-          </a:fillRef>
-          <a:effectRef idx="2">
-            <a:schemeClr val="accent1"/>
-          </a:effectRef>
-          <a:fontRef idx="minor">
-            <a:schemeClr val="lt1"/>
-          </a:fontRef>
-        </p:style>
-        <p:txBody>
-          <a:bodyPr rtlCol="0" anchor="ctr"/>
-          <a:lstStyle/>
-          <a:p>
-            <a:pPr algn="ctr"/>
-          </a:p>
-        </p:txBody>
-      </p:sp>
-      <p:sp>
-        <p:nvSpPr>
-          <p:cNvPr id="22" name="01"/>
-          <p:cNvSpPr txBox="1"/>
-          <p:nvPr/>
-        </p:nvSpPr>
-        <p:spPr>
-          <a:xfrm>
-            <a:off x="8467725" y="4543425"/>
-            <a:ext cx="666750" cy="666750"/>
-          </a:xfrm>
-          <a:prstGeom prst="rect">
-            <a:avLst/>
-          </a:prstGeom>
-          <a:noFill/>
-        </p:spPr>
-        <p:txBody>
-          <a:bodyPr wrap="square" lIns="0" rIns="0" tIns="10239" bIns="0" anchor="ctr">
-            <a:spAutoFit/>
-          </a:bodyPr>
-          <a:lstStyle/>
-          <a:p>
-            <a:pPr algn="ctr">
-              <a:lnSpc>
-                <a:spcPct val="100000"/>
-              </a:lnSpc>
-              <a:spcBef>
-                <a:spcPts val="0"/>
-              </a:spcBef>
-              <a:spcAft>
-                <a:spcPts val="0"/>
-              </a:spcAft>
-              <a:defRPr sz="1875" b="0">
-                <a:solidFill>
-                  <a:srgbClr val="FFFFFF"/>
-                </a:solidFill>
-                <a:latin typeface="Poppins SemiBold"/>
-              </a:defRPr>
-            </a:pPr>
-            <a:r>
-              <a:t>01</a:t>
-            </a:r>
-          </a:p>
-        </p:txBody>
-      </p:sp>
-      <p:sp>
-        <p:nvSpPr>
-          <p:cNvPr id="23" name="Text"/>
-          <p:cNvSpPr/>
-          <p:nvPr/>
-        </p:nvSpPr>
-        <p:spPr>
-          <a:xfrm>
-            <a:off x="10191750" y="3629025"/>
-            <a:ext cx="666750" cy="666750"/>
-          </a:xfrm>
-          <a:prstGeom prst="ellipse">
-            <a:avLst/>
-          </a:prstGeom>
-          <a:solidFill>
-            <a:srgbClr val="FFFFFF"/>
-          </a:solidFill>
-          <a:ln>
-            <a:noFill/>
-          </a:ln>
-        </p:spPr>
-        <p:style>
-          <a:lnRef idx="1">
-            <a:schemeClr val="accent1"/>
-          </a:lnRef>
-          <a:fillRef idx="3">
-            <a:schemeClr val="accent1"/>
-          </a:fillRef>
-          <a:effectRef idx="2">
-            <a:schemeClr val="accent1"/>
-          </a:effectRef>
-          <a:fontRef idx="minor">
-            <a:schemeClr val="lt1"/>
-          </a:fontRef>
-        </p:style>
-        <p:txBody>
-          <a:bodyPr rtlCol="0" anchor="ctr"/>
-          <a:lstStyle/>
-          <a:p>
-            <a:pPr algn="ctr"/>
-          </a:p>
-        </p:txBody>
-      </p:sp>
-      <p:sp>
-        <p:nvSpPr>
-          <p:cNvPr id="24" name="02"/>
-          <p:cNvSpPr txBox="1"/>
-          <p:nvPr/>
-        </p:nvSpPr>
-        <p:spPr>
-          <a:xfrm>
-            <a:off x="10191750" y="3629025"/>
-            <a:ext cx="666750" cy="666750"/>
-          </a:xfrm>
-          <a:prstGeom prst="rect">
-            <a:avLst/>
-          </a:prstGeom>
-          <a:noFill/>
-        </p:spPr>
-        <p:txBody>
-          <a:bodyPr wrap="square" lIns="0" rIns="0" tIns="10715" bIns="0" anchor="ctr">
-            <a:spAutoFit/>
-          </a:bodyPr>
-          <a:lstStyle/>
-          <a:p>
-            <a:pPr algn="ctr">
-              <a:lnSpc>
-                <a:spcPct val="100000"/>
-              </a:lnSpc>
-              <a:spcBef>
-                <a:spcPts val="0"/>
-              </a:spcBef>
-              <a:spcAft>
-                <a:spcPts val="0"/>
-              </a:spcAft>
-              <a:defRPr sz="1875" b="0">
-                <a:solidFill>
-                  <a:srgbClr val="1A1A1A"/>
-                </a:solidFill>
-                <a:latin typeface="Poppins SemiBold"/>
-              </a:defRPr>
-            </a:pPr>
-            <a:r>
-              <a:t>02</a:t>
-            </a:r>
-          </a:p>
-        </p:txBody>
-      </p:sp>
-      <p:sp>
-        <p:nvSpPr>
-          <p:cNvPr id="25" name="Text"/>
-          <p:cNvSpPr/>
-          <p:nvPr/>
-        </p:nvSpPr>
-        <p:spPr>
-          <a:xfrm>
-            <a:off x="8629650" y="2552700"/>
-            <a:ext cx="666750" cy="666750"/>
-          </a:xfrm>
-          <a:prstGeom prst="ellipse">
-            <a:avLst/>
-          </a:prstGeom>
-          <a:solidFill>
-            <a:srgbClr val="FFFFFF"/>
-          </a:solidFill>
-          <a:ln>
-            <a:noFill/>
-          </a:ln>
-        </p:spPr>
-        <p:style>
-          <a:lnRef idx="1">
-            <a:schemeClr val="accent1"/>
-          </a:lnRef>
-          <a:fillRef idx="3">
-            <a:schemeClr val="accent1"/>
-          </a:fillRef>
-          <a:effectRef idx="2">
-            <a:schemeClr val="accent1"/>
-          </a:effectRef>
-          <a:fontRef idx="minor">
-            <a:schemeClr val="lt1"/>
-          </a:fontRef>
-        </p:style>
-        <p:txBody>
-          <a:bodyPr rtlCol="0" anchor="ctr"/>
-          <a:lstStyle/>
-          <a:p>
-            <a:pPr algn="ctr"/>
-          </a:p>
-        </p:txBody>
-      </p:sp>
-      <p:sp>
-        <p:nvSpPr>
-          <p:cNvPr id="26" name="03"/>
-          <p:cNvSpPr txBox="1"/>
-          <p:nvPr/>
-        </p:nvSpPr>
-        <p:spPr>
-          <a:xfrm>
-            <a:off x="8629650" y="2552700"/>
-            <a:ext cx="666750" cy="666750"/>
-          </a:xfrm>
-          <a:prstGeom prst="rect">
-            <a:avLst/>
-          </a:prstGeom>
-          <a:noFill/>
-        </p:spPr>
-        <p:txBody>
-          <a:bodyPr wrap="square" lIns="0" rIns="0" tIns="9763" bIns="0" anchor="ctr">
-            <a:spAutoFit/>
-          </a:bodyPr>
-          <a:lstStyle/>
-          <a:p>
-            <a:pPr algn="ctr">
-              <a:lnSpc>
-                <a:spcPct val="100000"/>
-              </a:lnSpc>
-              <a:spcBef>
-                <a:spcPts val="0"/>
-              </a:spcBef>
-              <a:spcAft>
-                <a:spcPts val="0"/>
-              </a:spcAft>
-              <a:defRPr sz="1875" b="0">
-                <a:solidFill>
-                  <a:srgbClr val="1A1A1A"/>
-                </a:solidFill>
-                <a:latin typeface="Poppins SemiBold"/>
-              </a:defRPr>
-            </a:pPr>
-            <a:r>
-              <a:t>03</a:t>
-            </a:r>
-          </a:p>
-        </p:txBody>
-      </p:sp>
-      <p:sp>
-        <p:nvSpPr>
-          <p:cNvPr id="27" name="Text"/>
-          <p:cNvSpPr/>
-          <p:nvPr/>
-        </p:nvSpPr>
-        <p:spPr>
-          <a:xfrm>
-            <a:off x="10191750" y="1724025"/>
-            <a:ext cx="666750" cy="666750"/>
-          </a:xfrm>
-          <a:prstGeom prst="ellipse">
-            <a:avLst/>
-          </a:prstGeom>
-          <a:solidFill>
-            <a:srgbClr val="FFFFFF"/>
-          </a:solidFill>
-          <a:ln>
-            <a:noFill/>
-          </a:ln>
-        </p:spPr>
-        <p:style>
-          <a:lnRef idx="1">
-            <a:schemeClr val="accent1"/>
-          </a:lnRef>
-          <a:fillRef idx="3">
-            <a:schemeClr val="accent1"/>
-          </a:fillRef>
-          <a:effectRef idx="2">
-            <a:schemeClr val="accent1"/>
-          </a:effectRef>
-          <a:fontRef idx="minor">
-            <a:schemeClr val="lt1"/>
-          </a:fontRef>
-        </p:style>
-        <p:txBody>
-          <a:bodyPr rtlCol="0" anchor="ctr"/>
-          <a:lstStyle/>
-          <a:p>
-            <a:pPr algn="ctr"/>
-          </a:p>
-        </p:txBody>
-      </p:sp>
-      <p:sp>
-        <p:nvSpPr>
-          <p:cNvPr id="28" name="04"/>
-          <p:cNvSpPr txBox="1"/>
-          <p:nvPr/>
-        </p:nvSpPr>
-        <p:spPr>
-          <a:xfrm>
-            <a:off x="10191750" y="1724025"/>
-            <a:ext cx="666750" cy="666750"/>
-          </a:xfrm>
-          <a:prstGeom prst="rect">
-            <a:avLst/>
-          </a:prstGeom>
-          <a:noFill/>
-        </p:spPr>
-        <p:txBody>
-          <a:bodyPr wrap="square" lIns="0" rIns="0" tIns="10239" bIns="0" anchor="ctr">
-            <a:spAutoFit/>
-          </a:bodyPr>
-          <a:lstStyle/>
-          <a:p>
-            <a:pPr algn="ctr">
-              <a:lnSpc>
-                <a:spcPct val="100000"/>
-              </a:lnSpc>
-              <a:spcBef>
-                <a:spcPts val="0"/>
-              </a:spcBef>
-              <a:spcAft>
-                <a:spcPts val="0"/>
-              </a:spcAft>
-              <a:defRPr sz="1875" b="0">
-                <a:solidFill>
-                  <a:srgbClr val="1A1A1A"/>
-                </a:solidFill>
-                <a:latin typeface="Poppins SemiBold"/>
-              </a:defRPr>
-            </a:pPr>
-            <a:r>
-              <a:t>04</a:t>
-            </a:r>
-          </a:p>
-        </p:txBody>
-      </p:sp>
-      <p:sp>
-        <p:nvSpPr>
-          <p:cNvPr id="29" name="SCHRITT FÜR SCHRITT"/>
-          <p:cNvSpPr txBox="1"/>
-          <p:nvPr/>
-        </p:nvSpPr>
-        <p:spPr>
-          <a:xfrm>
-            <a:off x="8124824" y="5457825"/>
-            <a:ext cx="3143250" cy="266700"/>
-          </a:xfrm>
-          <a:prstGeom prst="rect">
-            <a:avLst/>
-          </a:prstGeom>
-          <a:noFill/>
-        </p:spPr>
-        <p:txBody>
-          <a:bodyPr wrap="square" lIns="0" rIns="0" tIns="0" bIns="0">
-            <a:spAutoFit/>
-          </a:bodyPr>
-          <a:lstStyle/>
-          <a:p>
-            <a:pPr algn="l">
-              <a:lnSpc>
-                <a:spcPct val="125000"/>
-              </a:lnSpc>
-              <a:spcBef>
-                <a:spcPts val="0"/>
-              </a:spcBef>
-              <a:spcAft>
-                <a:spcPts val="0"/>
-              </a:spcAft>
-              <a:defRPr sz="1050" b="0">
-                <a:solidFill>
-                  <a:srgbClr val="1A1A1A"/>
-                </a:solidFill>
-                <a:latin typeface="Poppins SemiBold"/>
-              </a:defRPr>
-            </a:pPr>
-            <a:r>
-              <a:t>SCHRITT FÜR SCHRITT</a:t>
             </a:r>
           </a:p>
         </p:txBody>

</xml_diff>